<commit_message>
update doc for added architecture
</commit_message>
<xml_diff>
--- a/class - 3/EDGE_2026_Lecture - 3.pptx
+++ b/class - 3/EDGE_2026_Lecture - 3.pptx
@@ -5,22 +5,23 @@
     <p:sldMasterId id="2147483660" r:id="rId4"/>
   </p:sldMasterIdLst>
   <p:notesMasterIdLst>
-    <p:notesMasterId r:id="rId15"/>
+    <p:notesMasterId r:id="rId16"/>
   </p:notesMasterIdLst>
   <p:handoutMasterIdLst>
-    <p:handoutMasterId r:id="rId16"/>
+    <p:handoutMasterId r:id="rId17"/>
   </p:handoutMasterIdLst>
   <p:sldIdLst>
     <p:sldId id="256" r:id="rId5"/>
     <p:sldId id="282" r:id="rId6"/>
     <p:sldId id="257" r:id="rId7"/>
     <p:sldId id="258" r:id="rId8"/>
-    <p:sldId id="284" r:id="rId9"/>
-    <p:sldId id="259" r:id="rId10"/>
-    <p:sldId id="283" r:id="rId11"/>
-    <p:sldId id="260" r:id="rId12"/>
-    <p:sldId id="270" r:id="rId13"/>
-    <p:sldId id="281" r:id="rId14"/>
+    <p:sldId id="285" r:id="rId9"/>
+    <p:sldId id="284" r:id="rId10"/>
+    <p:sldId id="259" r:id="rId11"/>
+    <p:sldId id="283" r:id="rId12"/>
+    <p:sldId id="260" r:id="rId13"/>
+    <p:sldId id="270" r:id="rId14"/>
+    <p:sldId id="281" r:id="rId15"/>
   </p:sldIdLst>
   <p:sldSz cx="12192000" cy="6858000"/>
   <p:notesSz cx="9144000" cy="6858000"/>
@@ -217,7 +218,7 @@
 <p1510:revInfo xmlns:a="http://schemas.openxmlformats.org/drawingml/2006/main" xmlns:r="http://schemas.openxmlformats.org/officeDocument/2006/relationships" xmlns:p1510="http://schemas.microsoft.com/office/powerpoint/2015/10/main">
   <p1510:revLst>
     <p1510:client id="{72EF0048-0589-7EFE-79F3-DDEDCD5CC2F6}" v="354" dt="2026-05-03T18:56:47.902"/>
-    <p1510:client id="{D4AD6D34-550B-AE94-1998-3C1B178D7F57}" v="148" dt="2026-05-05T15:22:54.841"/>
+    <p1510:client id="{D4AD6D34-550B-AE94-1998-3C1B178D7F57}" v="708" dt="2026-05-05T16:22:00.207"/>
   </p1510:revLst>
 </p1510:revInfo>
 </file>
@@ -4201,6 +4202,119 @@
         <p:cNvPr id="1" name="">
           <a:extLst>
             <a:ext uri="{FF2B5EF4-FFF2-40B4-BE49-F238E27FC236}">
+              <a16:creationId xmlns:a16="http://schemas.microsoft.com/office/drawing/2014/main" id="{0F599BD3-D82A-84A9-A47C-F08B04ADD907}"/>
+            </a:ext>
+          </a:extLst>
+        </p:cNvPr>
+        <p:cNvGrpSpPr/>
+        <p:nvPr/>
+      </p:nvGrpSpPr>
+      <p:grpSpPr>
+        <a:xfrm>
+          <a:off x="0" y="0"/>
+          <a:ext cx="0" cy="0"/>
+          <a:chOff x="0" y="0"/>
+          <a:chExt cx="0" cy="0"/>
+        </a:xfrm>
+      </p:grpSpPr>
+      <p:sp>
+        <p:nvSpPr>
+          <p:cNvPr id="2" name="Slide Image Placeholder 1">
+            <a:extLst>
+              <a:ext uri="{FF2B5EF4-FFF2-40B4-BE49-F238E27FC236}">
+                <a16:creationId xmlns:a16="http://schemas.microsoft.com/office/drawing/2014/main" id="{A5CF8ED7-191D-4219-02FD-A9FD54734871}"/>
+              </a:ext>
+            </a:extLst>
+          </p:cNvPr>
+          <p:cNvSpPr>
+            <a:spLocks noGrp="1" noRot="1" noChangeAspect="1"/>
+          </p:cNvSpPr>
+          <p:nvPr>
+            <p:ph type="sldImg"/>
+          </p:nvPr>
+        </p:nvSpPr>
+        <p:spPr>
+          <a:xfrm>
+            <a:off x="3978275" y="914400"/>
+            <a:ext cx="4387850" cy="2468563"/>
+          </a:xfrm>
+        </p:spPr>
+      </p:sp>
+      <p:sp>
+        <p:nvSpPr>
+          <p:cNvPr id="3" name="Notes Placeholder 2">
+            <a:extLst>
+              <a:ext uri="{FF2B5EF4-FFF2-40B4-BE49-F238E27FC236}">
+                <a16:creationId xmlns:a16="http://schemas.microsoft.com/office/drawing/2014/main" id="{EC09D77C-4503-7A87-B2BD-0A5CD963CC6F}"/>
+              </a:ext>
+            </a:extLst>
+          </p:cNvPr>
+          <p:cNvSpPr>
+            <a:spLocks noGrp="1"/>
+          </p:cNvSpPr>
+          <p:nvPr>
+            <p:ph type="body" idx="1"/>
+          </p:nvPr>
+        </p:nvSpPr>
+        <p:spPr/>
+        <p:txBody>
+          <a:bodyPr/>
+          <a:lstStyle/>
+          <a:p>
+            <a:endParaRPr lang="en-US" dirty="0"/>
+          </a:p>
+        </p:txBody>
+      </p:sp>
+      <p:sp>
+        <p:nvSpPr>
+          <p:cNvPr id="4" name="Slide Number Placeholder 3">
+            <a:extLst>
+              <a:ext uri="{FF2B5EF4-FFF2-40B4-BE49-F238E27FC236}">
+                <a16:creationId xmlns:a16="http://schemas.microsoft.com/office/drawing/2014/main" id="{EE8AED6E-D519-389F-F9CC-A69018EAA9B1}"/>
+              </a:ext>
+            </a:extLst>
+          </p:cNvPr>
+          <p:cNvSpPr>
+            <a:spLocks noGrp="1"/>
+          </p:cNvSpPr>
+          <p:nvPr>
+            <p:ph type="sldNum" sz="quarter" idx="10"/>
+          </p:nvPr>
+        </p:nvSpPr>
+        <p:spPr/>
+        <p:txBody>
+          <a:bodyPr/>
+          <a:lstStyle/>
+          <a:p>
+            <a:fld id="{F7021451-1387-4CA6-816F-3879F97B5CBC}" type="slidenum">
+              <a:rPr lang="en-US"/>
+              <a:t>5</a:t>
+            </a:fld>
+            <a:endParaRPr lang="en-US"/>
+          </a:p>
+        </p:txBody>
+      </p:sp>
+    </p:spTree>
+    <p:extLst>
+      <p:ext uri="{BB962C8B-B14F-4D97-AF65-F5344CB8AC3E}">
+        <p14:creationId xmlns:p14="http://schemas.microsoft.com/office/powerpoint/2010/main" val="2785154141"/>
+      </p:ext>
+    </p:extLst>
+  </p:cSld>
+  <p:clrMapOvr>
+    <a:masterClrMapping/>
+  </p:clrMapOvr>
+</p:notes>
+</file>
+
+<file path=ppt/notesSlides/notesSlide5.xml><?xml version="1.0" encoding="utf-8"?>
+<p:notes xmlns:a="http://schemas.openxmlformats.org/drawingml/2006/main" xmlns:r="http://schemas.openxmlformats.org/officeDocument/2006/relationships" xmlns:p="http://schemas.openxmlformats.org/presentationml/2006/main">
+  <p:cSld>
+    <p:spTree>
+      <p:nvGrpSpPr>
+        <p:cNvPr id="1" name="">
+          <a:extLst>
+            <a:ext uri="{FF2B5EF4-FFF2-40B4-BE49-F238E27FC236}">
               <a16:creationId xmlns:a16="http://schemas.microsoft.com/office/drawing/2014/main" id="{585A1169-C454-D690-BF04-9861D89EC437}"/>
             </a:ext>
           </a:extLst>
@@ -4306,7 +4420,7 @@
 </p:notes>
 </file>
 
-<file path=ppt/notesSlides/notesSlide5.xml><?xml version="1.0" encoding="utf-8"?>
+<file path=ppt/notesSlides/notesSlide6.xml><?xml version="1.0" encoding="utf-8"?>
 <p:notes xmlns:a="http://schemas.openxmlformats.org/drawingml/2006/main" xmlns:r="http://schemas.openxmlformats.org/officeDocument/2006/relationships" xmlns:p="http://schemas.openxmlformats.org/presentationml/2006/main">
   <p:cSld>
     <p:spTree>
@@ -4376,7 +4490,7 @@
           <a:p>
             <a:fld id="{F7021451-1387-4CA6-816F-3879F97B5CBC}" type="slidenum">
               <a:rPr lang="en-US"/>
-              <a:t>5</a:t>
+              <a:t>6</a:t>
             </a:fld>
             <a:endParaRPr lang="en-US"/>
           </a:p>
@@ -4395,7 +4509,7 @@
 </p:notes>
 </file>
 
-<file path=ppt/notesSlides/notesSlide6.xml><?xml version="1.0" encoding="utf-8"?>
+<file path=ppt/notesSlides/notesSlide7.xml><?xml version="1.0" encoding="utf-8"?>
 <p:notes xmlns:a="http://schemas.openxmlformats.org/drawingml/2006/main" xmlns:r="http://schemas.openxmlformats.org/officeDocument/2006/relationships" xmlns:p="http://schemas.openxmlformats.org/presentationml/2006/main">
   <p:cSld>
     <p:spTree>
@@ -4489,7 +4603,7 @@
           <a:p>
             <a:fld id="{F7021451-1387-4CA6-816F-3879F97B5CBC}" type="slidenum">
               <a:rPr lang="en-US"/>
-              <a:t>6</a:t>
+              <a:t>7</a:t>
             </a:fld>
             <a:endParaRPr lang="en-US"/>
           </a:p>
@@ -4508,7 +4622,7 @@
 </p:notes>
 </file>
 
-<file path=ppt/notesSlides/notesSlide7.xml><?xml version="1.0" encoding="utf-8"?>
+<file path=ppt/notesSlides/notesSlide8.xml><?xml version="1.0" encoding="utf-8"?>
 <p:notes xmlns:a="http://schemas.openxmlformats.org/drawingml/2006/main" xmlns:r="http://schemas.openxmlformats.org/officeDocument/2006/relationships" xmlns:p="http://schemas.openxmlformats.org/presentationml/2006/main">
   <p:cSld>
     <p:spTree>
@@ -4578,7 +4692,7 @@
           <a:p>
             <a:fld id="{F7021451-1387-4CA6-816F-3879F97B5CBC}" type="slidenum">
               <a:rPr lang="en-US"/>
-              <a:t>7</a:t>
+              <a:t>8</a:t>
             </a:fld>
             <a:endParaRPr lang="en-US"/>
           </a:p>
@@ -7056,6 +7170,117 @@
   <p:cSld>
     <p:spTree>
       <p:nvGrpSpPr>
+        <p:cNvPr id="1" name=""/>
+        <p:cNvGrpSpPr/>
+        <p:nvPr/>
+      </p:nvGrpSpPr>
+      <p:grpSpPr>
+        <a:xfrm>
+          <a:off x="0" y="0"/>
+          <a:ext cx="0" cy="0"/>
+          <a:chOff x="0" y="0"/>
+          <a:chExt cx="0" cy="0"/>
+        </a:xfrm>
+      </p:grpSpPr>
+      <p:sp>
+        <p:nvSpPr>
+          <p:cNvPr id="2" name="Title 1"/>
+          <p:cNvSpPr>
+            <a:spLocks noGrp="1"/>
+          </p:cNvSpPr>
+          <p:nvPr>
+            <p:ph type="title"/>
+          </p:nvPr>
+        </p:nvSpPr>
+        <p:spPr/>
+        <p:txBody>
+          <a:bodyPr/>
+          <a:lstStyle/>
+          <a:p>
+            <a:r>
+              <a:rPr lang="en-US"/>
+              <a:t>Q&amp;A</a:t>
+            </a:r>
+          </a:p>
+        </p:txBody>
+      </p:sp>
+      <p:sp>
+        <p:nvSpPr>
+          <p:cNvPr id="3" name="Slide Number Placeholder 2"/>
+          <p:cNvSpPr>
+            <a:spLocks noGrp="1"/>
+          </p:cNvSpPr>
+          <p:nvPr>
+            <p:ph type="sldNum" idx="12"/>
+          </p:nvPr>
+        </p:nvSpPr>
+        <p:spPr/>
+        <p:txBody>
+          <a:bodyPr/>
+          <a:lstStyle/>
+          <a:p>
+            <a:pPr algn="r"/>
+            <a:fld id="{CAD2D6BD-DE1B-4B5F-8B41-2702339687B9}" type="slidenum">
+              <a:rPr lang="en-US" altLang="zh-CN" smtClean="0">
+                <a:solidFill>
+                  <a:srgbClr val="888888"/>
+                </a:solidFill>
+                <a:ea typeface="Calibri" charset="0"/>
+                <a:sym typeface="Calibri" charset="0"/>
+              </a:rPr>
+              <a:pPr algn="r"/>
+              <a:t>10</a:t>
+            </a:fld>
+            <a:endParaRPr lang="zh-CN" altLang="en-US">
+              <a:solidFill>
+                <a:srgbClr val="888888"/>
+              </a:solidFill>
+              <a:ea typeface="Calibri" charset="0"/>
+              <a:sym typeface="Calibri" charset="0"/>
+            </a:endParaRPr>
+          </a:p>
+        </p:txBody>
+      </p:sp>
+      <p:sp>
+        <p:nvSpPr>
+          <p:cNvPr id="4" name="Text Placeholder 3"/>
+          <p:cNvSpPr>
+            <a:spLocks noGrp="1"/>
+          </p:cNvSpPr>
+          <p:nvPr>
+            <p:ph type="body" sz="quarter" idx="13"/>
+          </p:nvPr>
+        </p:nvSpPr>
+        <p:spPr/>
+        <p:txBody>
+          <a:bodyPr/>
+          <a:lstStyle/>
+          <a:p>
+            <a:r>
+              <a:rPr lang="en-US"/>
+              <a:t>Any Questions?</a:t>
+            </a:r>
+          </a:p>
+        </p:txBody>
+      </p:sp>
+    </p:spTree>
+    <p:extLst>
+      <p:ext uri="{BB962C8B-B14F-4D97-AF65-F5344CB8AC3E}">
+        <p14:creationId xmlns:p14="http://schemas.microsoft.com/office/powerpoint/2010/main" val="15486131"/>
+      </p:ext>
+    </p:extLst>
+  </p:cSld>
+  <p:clrMapOvr>
+    <a:masterClrMapping/>
+  </p:clrMapOvr>
+</p:sld>
+</file>
+
+<file path=ppt/slides/slide11.xml><?xml version="1.0" encoding="utf-8"?>
+<p:sld xmlns:a="http://schemas.openxmlformats.org/drawingml/2006/main" xmlns:r="http://schemas.openxmlformats.org/officeDocument/2006/relationships" xmlns:p="http://schemas.openxmlformats.org/presentationml/2006/main">
+  <p:cSld>
+    <p:spTree>
+      <p:nvGrpSpPr>
         <p:cNvPr id="1" name="">
           <a:extLst>
             <a:ext uri="{FF2B5EF4-FFF2-40B4-BE49-F238E27FC236}">
@@ -7105,7 +7330,7 @@
                 <a:sym typeface="Calibri" charset="0"/>
               </a:rPr>
               <a:pPr algn="r"/>
-              <a:t>10</a:t>
+              <a:t>11</a:t>
             </a:fld>
             <a:endParaRPr lang="zh-CN" altLang="en-US">
               <a:solidFill>
@@ -7360,6 +7585,22 @@
                 <a:cs typeface="Arial"/>
               </a:rPr>
               <a:t>Selenium</a:t>
+            </a:r>
+            <a:endParaRPr lang="en-US" dirty="0">
+              <a:latin typeface="Arial"/>
+              <a:cs typeface="Arial"/>
+            </a:endParaRPr>
+          </a:p>
+          <a:p>
+            <a:pPr marL="457200" indent="-457200">
+              <a:buAutoNum type="arabicPeriod"/>
+            </a:pPr>
+            <a:r>
+              <a:rPr lang="en-US">
+                <a:latin typeface="Arial"/>
+                <a:cs typeface="Arial"/>
+              </a:rPr>
+              <a:t>EDEG Chatbot Test automation Architecture </a:t>
             </a:r>
             <a:endParaRPr lang="en-US" dirty="0">
               <a:latin typeface="Arial"/>
@@ -11505,6 +11746,692 @@
         <p:cNvPr id="1" name="">
           <a:extLst>
             <a:ext uri="{FF2B5EF4-FFF2-40B4-BE49-F238E27FC236}">
+              <a16:creationId xmlns:a16="http://schemas.microsoft.com/office/drawing/2014/main" id="{FCC86AB9-9BF0-A7B3-DC70-3DCA373A418B}"/>
+            </a:ext>
+          </a:extLst>
+        </p:cNvPr>
+        <p:cNvGrpSpPr/>
+        <p:nvPr/>
+      </p:nvGrpSpPr>
+      <p:grpSpPr>
+        <a:xfrm>
+          <a:off x="0" y="0"/>
+          <a:ext cx="0" cy="0"/>
+          <a:chOff x="0" y="0"/>
+          <a:chExt cx="0" cy="0"/>
+        </a:xfrm>
+      </p:grpSpPr>
+      <p:sp>
+        <p:nvSpPr>
+          <p:cNvPr id="2" name="Shape 0">
+            <a:extLst>
+              <a:ext uri="{FF2B5EF4-FFF2-40B4-BE49-F238E27FC236}">
+                <a16:creationId xmlns:a16="http://schemas.microsoft.com/office/drawing/2014/main" id="{64A39946-54AD-0493-09ED-2828FCCA4964}"/>
+              </a:ext>
+            </a:extLst>
+          </p:cNvPr>
+          <p:cNvSpPr/>
+          <p:nvPr/>
+        </p:nvSpPr>
+        <p:spPr>
+          <a:xfrm>
+            <a:off x="0" y="0"/>
+            <a:ext cx="12192000" cy="1219200"/>
+          </a:xfrm>
+          <a:prstGeom prst="rect">
+            <a:avLst/>
+          </a:prstGeom>
+          <a:solidFill>
+            <a:srgbClr val="1B3A5C"/>
+          </a:solidFill>
+          <a:ln w="12700">
+            <a:solidFill>
+              <a:srgbClr val="1B3A5C"/>
+            </a:solidFill>
+            <a:prstDash val="solid"/>
+          </a:ln>
+        </p:spPr>
+      </p:sp>
+      <p:sp>
+        <p:nvSpPr>
+          <p:cNvPr id="4" name="Text 2">
+            <a:extLst>
+              <a:ext uri="{FF2B5EF4-FFF2-40B4-BE49-F238E27FC236}">
+                <a16:creationId xmlns:a16="http://schemas.microsoft.com/office/drawing/2014/main" id="{24AE6751-DA63-ED86-098D-25DAB32905EC}"/>
+              </a:ext>
+            </a:extLst>
+          </p:cNvPr>
+          <p:cNvSpPr/>
+          <p:nvPr/>
+        </p:nvSpPr>
+        <p:spPr>
+          <a:xfrm>
+            <a:off x="243840" y="121920"/>
+            <a:ext cx="1097280" cy="975360"/>
+          </a:xfrm>
+          <a:prstGeom prst="rect">
+            <a:avLst/>
+          </a:prstGeom>
+          <a:noFill/>
+          <a:ln/>
+        </p:spPr>
+        <p:txBody>
+          <a:bodyPr wrap="square" lIns="0" tIns="0" rIns="0" bIns="0" rtlCol="0" anchor="ctr"/>
+          <a:lstStyle>
+            <a:lvl1pPr marL="0" algn="l" defTabSz="1219170" rtl="0" eaLnBrk="1" latinLnBrk="0" hangingPunct="1">
+              <a:defRPr sz="2400" kern="1200">
+                <a:solidFill>
+                  <a:schemeClr val="tx1"/>
+                </a:solidFill>
+                <a:latin typeface="+mn-lt"/>
+                <a:ea typeface="+mn-ea"/>
+                <a:cs typeface="+mn-cs"/>
+              </a:defRPr>
+            </a:lvl1pPr>
+            <a:lvl2pPr marL="609585" algn="l" defTabSz="1219170" rtl="0" eaLnBrk="1" latinLnBrk="0" hangingPunct="1">
+              <a:defRPr sz="2400" kern="1200">
+                <a:solidFill>
+                  <a:schemeClr val="tx1"/>
+                </a:solidFill>
+                <a:latin typeface="+mn-lt"/>
+                <a:ea typeface="+mn-ea"/>
+                <a:cs typeface="+mn-cs"/>
+              </a:defRPr>
+            </a:lvl2pPr>
+            <a:lvl3pPr marL="1219170" algn="l" defTabSz="1219170" rtl="0" eaLnBrk="1" latinLnBrk="0" hangingPunct="1">
+              <a:defRPr sz="2400" kern="1200">
+                <a:solidFill>
+                  <a:schemeClr val="tx1"/>
+                </a:solidFill>
+                <a:latin typeface="+mn-lt"/>
+                <a:ea typeface="+mn-ea"/>
+                <a:cs typeface="+mn-cs"/>
+              </a:defRPr>
+            </a:lvl3pPr>
+            <a:lvl4pPr marL="1828754" algn="l" defTabSz="1219170" rtl="0" eaLnBrk="1" latinLnBrk="0" hangingPunct="1">
+              <a:defRPr sz="2400" kern="1200">
+                <a:solidFill>
+                  <a:schemeClr val="tx1"/>
+                </a:solidFill>
+                <a:latin typeface="+mn-lt"/>
+                <a:ea typeface="+mn-ea"/>
+                <a:cs typeface="+mn-cs"/>
+              </a:defRPr>
+            </a:lvl4pPr>
+            <a:lvl5pPr marL="2438339" algn="l" defTabSz="1219170" rtl="0" eaLnBrk="1" latinLnBrk="0" hangingPunct="1">
+              <a:defRPr sz="2400" kern="1200">
+                <a:solidFill>
+                  <a:schemeClr val="tx1"/>
+                </a:solidFill>
+                <a:latin typeface="+mn-lt"/>
+                <a:ea typeface="+mn-ea"/>
+                <a:cs typeface="+mn-cs"/>
+              </a:defRPr>
+            </a:lvl5pPr>
+            <a:lvl6pPr marL="3047924" algn="l" defTabSz="1219170" rtl="0" eaLnBrk="1" latinLnBrk="0" hangingPunct="1">
+              <a:defRPr sz="2400" kern="1200">
+                <a:solidFill>
+                  <a:schemeClr val="tx1"/>
+                </a:solidFill>
+                <a:latin typeface="+mn-lt"/>
+                <a:ea typeface="+mn-ea"/>
+                <a:cs typeface="+mn-cs"/>
+              </a:defRPr>
+            </a:lvl6pPr>
+            <a:lvl7pPr marL="3657509" algn="l" defTabSz="1219170" rtl="0" eaLnBrk="1" latinLnBrk="0" hangingPunct="1">
+              <a:defRPr sz="2400" kern="1200">
+                <a:solidFill>
+                  <a:schemeClr val="tx1"/>
+                </a:solidFill>
+                <a:latin typeface="+mn-lt"/>
+                <a:ea typeface="+mn-ea"/>
+                <a:cs typeface="+mn-cs"/>
+              </a:defRPr>
+            </a:lvl7pPr>
+            <a:lvl8pPr marL="4267093" algn="l" defTabSz="1219170" rtl="0" eaLnBrk="1" latinLnBrk="0" hangingPunct="1">
+              <a:defRPr sz="2400" kern="1200">
+                <a:solidFill>
+                  <a:schemeClr val="tx1"/>
+                </a:solidFill>
+                <a:latin typeface="+mn-lt"/>
+                <a:ea typeface="+mn-ea"/>
+                <a:cs typeface="+mn-cs"/>
+              </a:defRPr>
+            </a:lvl8pPr>
+            <a:lvl9pPr marL="4876678" algn="l" defTabSz="1219170" rtl="0" eaLnBrk="1" latinLnBrk="0" hangingPunct="1">
+              <a:defRPr sz="2400" kern="1200">
+                <a:solidFill>
+                  <a:schemeClr val="tx1"/>
+                </a:solidFill>
+                <a:latin typeface="+mn-lt"/>
+                <a:ea typeface="+mn-ea"/>
+                <a:cs typeface="+mn-cs"/>
+              </a:defRPr>
+            </a:lvl9pPr>
+          </a:lstStyle>
+          <a:p>
+            <a:pPr marL="0" indent="0">
+              <a:buNone/>
+            </a:pPr>
+            <a:endParaRPr lang="en-US" sz="2650" b="1" dirty="0">
+              <a:solidFill>
+                <a:srgbClr val="0E9F8E"/>
+              </a:solidFill>
+              <a:latin typeface="Arial Black"/>
+            </a:endParaRPr>
+          </a:p>
+        </p:txBody>
+      </p:sp>
+      <p:sp>
+        <p:nvSpPr>
+          <p:cNvPr id="5" name="Text 3">
+            <a:extLst>
+              <a:ext uri="{FF2B5EF4-FFF2-40B4-BE49-F238E27FC236}">
+                <a16:creationId xmlns:a16="http://schemas.microsoft.com/office/drawing/2014/main" id="{D481199A-F98C-6C4F-AADD-E292E5C6A468}"/>
+              </a:ext>
+            </a:extLst>
+          </p:cNvPr>
+          <p:cNvSpPr/>
+          <p:nvPr/>
+        </p:nvSpPr>
+        <p:spPr>
+          <a:xfrm>
+            <a:off x="364197" y="126766"/>
+            <a:ext cx="11015784" cy="970514"/>
+          </a:xfrm>
+          <a:prstGeom prst="rect">
+            <a:avLst/>
+          </a:prstGeom>
+          <a:noFill/>
+          <a:ln/>
+        </p:spPr>
+        <p:txBody>
+          <a:bodyPr wrap="square" lIns="0" tIns="0" rIns="0" bIns="0" rtlCol="0" anchor="ctr"/>
+          <a:lstStyle>
+            <a:lvl1pPr marL="0" algn="l" defTabSz="1219170" rtl="0" eaLnBrk="1" latinLnBrk="0" hangingPunct="1">
+              <a:defRPr sz="2400" kern="1200">
+                <a:solidFill>
+                  <a:schemeClr val="tx1"/>
+                </a:solidFill>
+                <a:latin typeface="+mn-lt"/>
+                <a:ea typeface="+mn-ea"/>
+                <a:cs typeface="+mn-cs"/>
+              </a:defRPr>
+            </a:lvl1pPr>
+            <a:lvl2pPr marL="609585" algn="l" defTabSz="1219170" rtl="0" eaLnBrk="1" latinLnBrk="0" hangingPunct="1">
+              <a:defRPr sz="2400" kern="1200">
+                <a:solidFill>
+                  <a:schemeClr val="tx1"/>
+                </a:solidFill>
+                <a:latin typeface="+mn-lt"/>
+                <a:ea typeface="+mn-ea"/>
+                <a:cs typeface="+mn-cs"/>
+              </a:defRPr>
+            </a:lvl2pPr>
+            <a:lvl3pPr marL="1219170" algn="l" defTabSz="1219170" rtl="0" eaLnBrk="1" latinLnBrk="0" hangingPunct="1">
+              <a:defRPr sz="2400" kern="1200">
+                <a:solidFill>
+                  <a:schemeClr val="tx1"/>
+                </a:solidFill>
+                <a:latin typeface="+mn-lt"/>
+                <a:ea typeface="+mn-ea"/>
+                <a:cs typeface="+mn-cs"/>
+              </a:defRPr>
+            </a:lvl3pPr>
+            <a:lvl4pPr marL="1828754" algn="l" defTabSz="1219170" rtl="0" eaLnBrk="1" latinLnBrk="0" hangingPunct="1">
+              <a:defRPr sz="2400" kern="1200">
+                <a:solidFill>
+                  <a:schemeClr val="tx1"/>
+                </a:solidFill>
+                <a:latin typeface="+mn-lt"/>
+                <a:ea typeface="+mn-ea"/>
+                <a:cs typeface="+mn-cs"/>
+              </a:defRPr>
+            </a:lvl4pPr>
+            <a:lvl5pPr marL="2438339" algn="l" defTabSz="1219170" rtl="0" eaLnBrk="1" latinLnBrk="0" hangingPunct="1">
+              <a:defRPr sz="2400" kern="1200">
+                <a:solidFill>
+                  <a:schemeClr val="tx1"/>
+                </a:solidFill>
+                <a:latin typeface="+mn-lt"/>
+                <a:ea typeface="+mn-ea"/>
+                <a:cs typeface="+mn-cs"/>
+              </a:defRPr>
+            </a:lvl5pPr>
+            <a:lvl6pPr marL="3047924" algn="l" defTabSz="1219170" rtl="0" eaLnBrk="1" latinLnBrk="0" hangingPunct="1">
+              <a:defRPr sz="2400" kern="1200">
+                <a:solidFill>
+                  <a:schemeClr val="tx1"/>
+                </a:solidFill>
+                <a:latin typeface="+mn-lt"/>
+                <a:ea typeface="+mn-ea"/>
+                <a:cs typeface="+mn-cs"/>
+              </a:defRPr>
+            </a:lvl6pPr>
+            <a:lvl7pPr marL="3657509" algn="l" defTabSz="1219170" rtl="0" eaLnBrk="1" latinLnBrk="0" hangingPunct="1">
+              <a:defRPr sz="2400" kern="1200">
+                <a:solidFill>
+                  <a:schemeClr val="tx1"/>
+                </a:solidFill>
+                <a:latin typeface="+mn-lt"/>
+                <a:ea typeface="+mn-ea"/>
+                <a:cs typeface="+mn-cs"/>
+              </a:defRPr>
+            </a:lvl7pPr>
+            <a:lvl8pPr marL="4267093" algn="l" defTabSz="1219170" rtl="0" eaLnBrk="1" latinLnBrk="0" hangingPunct="1">
+              <a:defRPr sz="2400" kern="1200">
+                <a:solidFill>
+                  <a:schemeClr val="tx1"/>
+                </a:solidFill>
+                <a:latin typeface="+mn-lt"/>
+                <a:ea typeface="+mn-ea"/>
+                <a:cs typeface="+mn-cs"/>
+              </a:defRPr>
+            </a:lvl8pPr>
+            <a:lvl9pPr marL="4876678" algn="l" defTabSz="1219170" rtl="0" eaLnBrk="1" latinLnBrk="0" hangingPunct="1">
+              <a:defRPr sz="2400" kern="1200">
+                <a:solidFill>
+                  <a:schemeClr val="tx1"/>
+                </a:solidFill>
+                <a:latin typeface="+mn-lt"/>
+                <a:ea typeface="+mn-ea"/>
+                <a:cs typeface="+mn-cs"/>
+              </a:defRPr>
+            </a:lvl9pPr>
+          </a:lstStyle>
+          <a:p>
+            <a:r>
+              <a:rPr lang="en-US" sz="3450" b="1" dirty="0">
+                <a:solidFill>
+                  <a:srgbClr val="FFFFFF"/>
+                </a:solidFill>
+                <a:latin typeface="Arial Black"/>
+              </a:rPr>
+              <a:t>EDEG Chatbot Test automation </a:t>
+            </a:r>
+            <a:r>
+              <a:rPr lang="en-US" sz="3450" b="1">
+                <a:solidFill>
+                  <a:srgbClr val="FFFFFF"/>
+                </a:solidFill>
+                <a:latin typeface="Arial Black"/>
+              </a:rPr>
+              <a:t>Architecture</a:t>
+            </a:r>
+            <a:endParaRPr lang="en-US" sz="3450" b="1" dirty="0">
+              <a:solidFill>
+                <a:srgbClr val="FFFFFF"/>
+              </a:solidFill>
+              <a:latin typeface="Arial Black"/>
+            </a:endParaRPr>
+          </a:p>
+        </p:txBody>
+      </p:sp>
+      <p:pic>
+        <p:nvPicPr>
+          <p:cNvPr id="33" name="Graphic 32">
+            <a:extLst>
+              <a:ext uri="{FF2B5EF4-FFF2-40B4-BE49-F238E27FC236}">
+                <a16:creationId xmlns:a16="http://schemas.microsoft.com/office/drawing/2014/main" id="{861F9DE6-68BB-FF74-05A8-B74436F894EB}"/>
+              </a:ext>
+            </a:extLst>
+          </p:cNvPr>
+          <p:cNvPicPr>
+            <a:picLocks noChangeAspect="1"/>
+          </p:cNvPicPr>
+          <p:nvPr/>
+        </p:nvPicPr>
+        <p:blipFill>
+          <a:blip>
+            <a:extLst>
+              <a:ext uri="{96DAC541-7B7A-43D3-8B79-37D633B846F1}">
+                <asvg:svgBlip xmlns:asvg="http://schemas.microsoft.com/office/drawing/2016/SVG/main" r:embed="rId3"/>
+              </a:ext>
+            </a:extLst>
+          </a:blip>
+          <a:stretch>
+            <a:fillRect/>
+          </a:stretch>
+        </p:blipFill>
+        <p:spPr>
+          <a:xfrm>
+            <a:off x="6766490" y="1445683"/>
+            <a:ext cx="4289354" cy="4643966"/>
+          </a:xfrm>
+          <a:prstGeom prst="rect">
+            <a:avLst/>
+          </a:prstGeom>
+        </p:spPr>
+      </p:pic>
+      <p:sp>
+        <p:nvSpPr>
+          <p:cNvPr id="35" name="Shape 4">
+            <a:extLst>
+              <a:ext uri="{FF2B5EF4-FFF2-40B4-BE49-F238E27FC236}">
+                <a16:creationId xmlns:a16="http://schemas.microsoft.com/office/drawing/2014/main" id="{22115C0B-5F25-5D6B-5444-AF5C918493C6}"/>
+              </a:ext>
+            </a:extLst>
+          </p:cNvPr>
+          <p:cNvSpPr/>
+          <p:nvPr/>
+        </p:nvSpPr>
+        <p:spPr>
+          <a:xfrm>
+            <a:off x="365760" y="1402080"/>
+            <a:ext cx="5427785" cy="4720493"/>
+          </a:xfrm>
+          <a:prstGeom prst="rect">
+            <a:avLst/>
+          </a:prstGeom>
+          <a:solidFill>
+            <a:srgbClr val="1B3A5C"/>
+          </a:solidFill>
+          <a:ln/>
+          <a:effectLst>
+            <a:outerShdw blurRad="101600" dist="38100" dir="8100000" algn="bl" rotWithShape="0">
+              <a:srgbClr val="000000">
+                <a:alpha val="30000"/>
+              </a:srgbClr>
+            </a:outerShdw>
+          </a:effectLst>
+        </p:spPr>
+      </p:sp>
+      <p:sp>
+        <p:nvSpPr>
+          <p:cNvPr id="36" name="TextBox 35">
+            <a:extLst>
+              <a:ext uri="{FF2B5EF4-FFF2-40B4-BE49-F238E27FC236}">
+                <a16:creationId xmlns:a16="http://schemas.microsoft.com/office/drawing/2014/main" id="{F101E519-FF66-65D0-9956-1AA5365BA5DC}"/>
+              </a:ext>
+            </a:extLst>
+          </p:cNvPr>
+          <p:cNvSpPr txBox="1"/>
+          <p:nvPr/>
+        </p:nvSpPr>
+        <p:spPr>
+          <a:xfrm>
+            <a:off x="444500" y="1608666"/>
+            <a:ext cx="4984750" cy="2862322"/>
+          </a:xfrm>
+          <a:prstGeom prst="rect">
+            <a:avLst/>
+          </a:prstGeom>
+          <a:noFill/>
+        </p:spPr>
+        <p:txBody>
+          <a:bodyPr rot="0" spcFirstLastPara="0" vertOverflow="overflow" horzOverflow="overflow" vert="horz" wrap="square" lIns="91440" tIns="45720" rIns="91440" bIns="45720" numCol="1" spcCol="0" rtlCol="0" fromWordArt="0" anchor="t" anchorCtr="0" forceAA="0" compatLnSpc="1">
+            <a:prstTxWarp prst="textNoShape">
+              <a:avLst/>
+            </a:prstTxWarp>
+            <a:spAutoFit/>
+          </a:bodyPr>
+          <a:lstStyle/>
+          <a:p>
+            <a:pPr marL="285750" indent="-285750">
+              <a:buFont typeface="Arial"/>
+              <a:buChar char="•"/>
+            </a:pPr>
+            <a:r>
+              <a:rPr lang="en-US" sz="2000">
+                <a:solidFill>
+                  <a:schemeClr val="bg1"/>
+                </a:solidFill>
+                <a:latin typeface="Arial"/>
+                <a:cs typeface="Arial"/>
+              </a:rPr>
+              <a:t>Start from main function</a:t>
+            </a:r>
+            <a:endParaRPr lang="en-US" sz="2000" dirty="0">
+              <a:solidFill>
+                <a:schemeClr val="bg1"/>
+              </a:solidFill>
+              <a:latin typeface="Arial"/>
+              <a:cs typeface="Arial"/>
+            </a:endParaRPr>
+          </a:p>
+          <a:p>
+            <a:pPr marL="285750" indent="-285750">
+              <a:buFont typeface="Arial"/>
+              <a:buChar char="•"/>
+            </a:pPr>
+            <a:r>
+              <a:rPr lang="en-US" sz="2000">
+                <a:solidFill>
+                  <a:schemeClr val="bg1"/>
+                </a:solidFill>
+                <a:latin typeface="Arial"/>
+                <a:cs typeface="Arial"/>
+              </a:rPr>
+              <a:t>Checking test file available or not</a:t>
+            </a:r>
+            <a:endParaRPr lang="en-US" sz="2000" dirty="0">
+              <a:solidFill>
+                <a:schemeClr val="bg1"/>
+              </a:solidFill>
+              <a:latin typeface="Arial"/>
+              <a:cs typeface="Arial"/>
+            </a:endParaRPr>
+          </a:p>
+          <a:p>
+            <a:pPr marL="285750" indent="-285750">
+              <a:buFont typeface="Arial"/>
+              <a:buChar char="•"/>
+            </a:pPr>
+            <a:r>
+              <a:rPr lang="en-US" sz="2000" dirty="0">
+                <a:solidFill>
+                  <a:schemeClr val="bg1"/>
+                </a:solidFill>
+                <a:latin typeface="Arial"/>
+                <a:cs typeface="Arial"/>
+              </a:rPr>
+              <a:t>Result folder </a:t>
+            </a:r>
+            <a:r>
+              <a:rPr lang="en-US" sz="2000">
+                <a:solidFill>
+                  <a:schemeClr val="bg1"/>
+                </a:solidFill>
+                <a:latin typeface="Arial"/>
+                <a:cs typeface="Arial"/>
+              </a:rPr>
+              <a:t>checking</a:t>
+            </a:r>
+            <a:endParaRPr lang="en-US" sz="2000" dirty="0">
+              <a:solidFill>
+                <a:schemeClr val="bg1"/>
+              </a:solidFill>
+              <a:latin typeface="Arial"/>
+              <a:cs typeface="Arial"/>
+            </a:endParaRPr>
+          </a:p>
+          <a:p>
+            <a:pPr marL="285750" indent="-285750">
+              <a:buFont typeface="Arial"/>
+              <a:buChar char="•"/>
+            </a:pPr>
+            <a:r>
+              <a:rPr lang="en-US" sz="2000">
+                <a:solidFill>
+                  <a:schemeClr val="bg1"/>
+                </a:solidFill>
+                <a:latin typeface="Arial"/>
+                <a:cs typeface="Arial"/>
+              </a:rPr>
+              <a:t>Launch app in Chrome browser</a:t>
+            </a:r>
+            <a:endParaRPr lang="en-US" sz="2000" dirty="0">
+              <a:solidFill>
+                <a:schemeClr val="bg1"/>
+              </a:solidFill>
+              <a:latin typeface="Arial"/>
+              <a:cs typeface="Arial"/>
+            </a:endParaRPr>
+          </a:p>
+          <a:p>
+            <a:pPr marL="285750" indent="-285750">
+              <a:buFont typeface="Arial"/>
+              <a:buChar char="•"/>
+            </a:pPr>
+            <a:r>
+              <a:rPr lang="en-US" sz="2000">
+                <a:solidFill>
+                  <a:schemeClr val="bg1"/>
+                </a:solidFill>
+                <a:latin typeface="Arial"/>
+                <a:cs typeface="Arial"/>
+              </a:rPr>
+              <a:t>Wait for ready</a:t>
+            </a:r>
+            <a:endParaRPr lang="en-US" sz="2000" dirty="0">
+              <a:solidFill>
+                <a:schemeClr val="bg1"/>
+              </a:solidFill>
+              <a:latin typeface="Arial"/>
+              <a:cs typeface="Arial"/>
+            </a:endParaRPr>
+          </a:p>
+          <a:p>
+            <a:pPr marL="285750" indent="-285750">
+              <a:buFont typeface="Arial"/>
+              <a:buChar char="•"/>
+            </a:pPr>
+            <a:r>
+              <a:rPr lang="en-US" sz="2000">
+                <a:solidFill>
+                  <a:schemeClr val="bg1"/>
+                </a:solidFill>
+                <a:latin typeface="Arial"/>
+                <a:cs typeface="Arial"/>
+              </a:rPr>
+              <a:t>Put prompt into the chatbot</a:t>
+            </a:r>
+            <a:endParaRPr lang="en-US" sz="2000" dirty="0">
+              <a:solidFill>
+                <a:schemeClr val="bg1"/>
+              </a:solidFill>
+              <a:latin typeface="Arial"/>
+              <a:cs typeface="Arial"/>
+            </a:endParaRPr>
+          </a:p>
+          <a:p>
+            <a:pPr marL="285750" indent="-285750">
+              <a:buFont typeface="Arial"/>
+              <a:buChar char="•"/>
+            </a:pPr>
+            <a:r>
+              <a:rPr lang="en-US" sz="2000">
+                <a:solidFill>
+                  <a:schemeClr val="bg1"/>
+                </a:solidFill>
+                <a:latin typeface="Arial"/>
+                <a:cs typeface="Arial"/>
+              </a:rPr>
+              <a:t>Get response</a:t>
+            </a:r>
+            <a:endParaRPr lang="en-US" sz="2000" dirty="0">
+              <a:solidFill>
+                <a:schemeClr val="bg1"/>
+              </a:solidFill>
+              <a:latin typeface="Arial"/>
+              <a:cs typeface="Arial"/>
+            </a:endParaRPr>
+          </a:p>
+          <a:p>
+            <a:pPr marL="285750" indent="-285750">
+              <a:buFont typeface="Arial"/>
+              <a:buChar char="•"/>
+            </a:pPr>
+            <a:r>
+              <a:rPr lang="en-US" sz="2000" dirty="0">
+                <a:solidFill>
+                  <a:schemeClr val="bg1"/>
+                </a:solidFill>
+                <a:latin typeface="Arial"/>
+                <a:cs typeface="Arial"/>
+              </a:rPr>
+              <a:t>Test response by the simple </a:t>
+            </a:r>
+            <a:r>
+              <a:rPr lang="en-US" sz="2000">
+                <a:solidFill>
+                  <a:schemeClr val="bg1"/>
+                </a:solidFill>
+                <a:latin typeface="Arial"/>
+                <a:cs typeface="Arial"/>
+              </a:rPr>
+              <a:t>formula</a:t>
+            </a:r>
+            <a:endParaRPr lang="en-US" sz="2000" dirty="0">
+              <a:solidFill>
+                <a:schemeClr val="bg1"/>
+              </a:solidFill>
+              <a:latin typeface="Arial"/>
+              <a:cs typeface="Arial"/>
+            </a:endParaRPr>
+          </a:p>
+          <a:p>
+            <a:pPr marL="285750" indent="-285750">
+              <a:buFont typeface="Arial"/>
+              <a:buChar char="•"/>
+            </a:pPr>
+            <a:r>
+              <a:rPr lang="en-US" sz="2000" dirty="0">
+                <a:solidFill>
+                  <a:schemeClr val="bg1"/>
+                </a:solidFill>
+                <a:latin typeface="Arial"/>
+                <a:cs typeface="Arial"/>
+              </a:rPr>
+              <a:t>Same test </a:t>
+            </a:r>
+            <a:r>
+              <a:rPr lang="en-US" sz="2000">
+                <a:solidFill>
+                  <a:schemeClr val="bg1"/>
+                </a:solidFill>
+                <a:latin typeface="Arial"/>
+                <a:cs typeface="Arial"/>
+              </a:rPr>
+              <a:t>result</a:t>
+            </a:r>
+            <a:endParaRPr lang="en-US" sz="2000">
+              <a:solidFill>
+                <a:schemeClr val="bg1"/>
+              </a:solidFill>
+            </a:endParaRPr>
+          </a:p>
+        </p:txBody>
+      </p:sp>
+    </p:spTree>
+    <p:extLst>
+      <p:ext uri="{BB962C8B-B14F-4D97-AF65-F5344CB8AC3E}">
+        <p14:creationId xmlns:p14="http://schemas.microsoft.com/office/powerpoint/2010/main" val="986844496"/>
+      </p:ext>
+    </p:extLst>
+  </p:cSld>
+  <p:clrMapOvr>
+    <a:masterClrMapping/>
+  </p:clrMapOvr>
+</p:sld>
+</file>
+
+<file path=ppt/slides/slide6.xml><?xml version="1.0" encoding="utf-8"?>
+<p:sld xmlns:a="http://schemas.openxmlformats.org/drawingml/2006/main" xmlns:r="http://schemas.openxmlformats.org/officeDocument/2006/relationships" xmlns:p="http://schemas.openxmlformats.org/presentationml/2006/main">
+  <p:cSld>
+    <p:bg>
+      <p:bgPr>
+        <a:solidFill>
+          <a:srgbClr val="0D1B2A"/>
+        </a:solidFill>
+        <a:effectLst/>
+      </p:bgPr>
+    </p:bg>
+    <p:spTree>
+      <p:nvGrpSpPr>
+        <p:cNvPr id="1" name="">
+          <a:extLst>
+            <a:ext uri="{FF2B5EF4-FFF2-40B4-BE49-F238E27FC236}">
               <a16:creationId xmlns:a16="http://schemas.microsoft.com/office/drawing/2014/main" id="{0AD7FB9C-35FF-C347-C093-ACF27818E482}"/>
             </a:ext>
           </a:extLst>
@@ -12866,7 +13793,7 @@
 </p:sld>
 </file>
 
-<file path=ppt/slides/slide6.xml><?xml version="1.0" encoding="utf-8"?>
+<file path=ppt/slides/slide7.xml><?xml version="1.0" encoding="utf-8"?>
 <p:sld xmlns:a="http://schemas.openxmlformats.org/drawingml/2006/main" xmlns:r="http://schemas.openxmlformats.org/officeDocument/2006/relationships" xmlns:p="http://schemas.openxmlformats.org/presentationml/2006/main">
   <p:cSld name="Slide 4">
     <p:bg>
@@ -15713,7 +16640,7 @@
 </p:sld>
 </file>
 
-<file path=ppt/slides/slide7.xml><?xml version="1.0" encoding="utf-8"?>
+<file path=ppt/slides/slide8.xml><?xml version="1.0" encoding="utf-8"?>
 <p:sld xmlns:a="http://schemas.openxmlformats.org/drawingml/2006/main" xmlns:r="http://schemas.openxmlformats.org/officeDocument/2006/relationships" xmlns:p="http://schemas.openxmlformats.org/presentationml/2006/main">
   <p:cSld>
     <p:bg>
@@ -18938,7 +19865,7 @@
 </p:sld>
 </file>
 
-<file path=ppt/slides/slide8.xml><?xml version="1.0" encoding="utf-8"?>
+<file path=ppt/slides/slide9.xml><?xml version="1.0" encoding="utf-8"?>
 <p:sld xmlns:a="http://schemas.openxmlformats.org/drawingml/2006/main" xmlns:r="http://schemas.openxmlformats.org/officeDocument/2006/relationships" xmlns:p="http://schemas.openxmlformats.org/presentationml/2006/main">
   <p:cSld name="Slide 5">
     <p:bg>
@@ -21370,117 +22297,6 @@
         </p:txBody>
       </p:sp>
     </p:spTree>
-  </p:cSld>
-  <p:clrMapOvr>
-    <a:masterClrMapping/>
-  </p:clrMapOvr>
-</p:sld>
-</file>
-
-<file path=ppt/slides/slide9.xml><?xml version="1.0" encoding="utf-8"?>
-<p:sld xmlns:a="http://schemas.openxmlformats.org/drawingml/2006/main" xmlns:r="http://schemas.openxmlformats.org/officeDocument/2006/relationships" xmlns:p="http://schemas.openxmlformats.org/presentationml/2006/main">
-  <p:cSld>
-    <p:spTree>
-      <p:nvGrpSpPr>
-        <p:cNvPr id="1" name=""/>
-        <p:cNvGrpSpPr/>
-        <p:nvPr/>
-      </p:nvGrpSpPr>
-      <p:grpSpPr>
-        <a:xfrm>
-          <a:off x="0" y="0"/>
-          <a:ext cx="0" cy="0"/>
-          <a:chOff x="0" y="0"/>
-          <a:chExt cx="0" cy="0"/>
-        </a:xfrm>
-      </p:grpSpPr>
-      <p:sp>
-        <p:nvSpPr>
-          <p:cNvPr id="2" name="Title 1"/>
-          <p:cNvSpPr>
-            <a:spLocks noGrp="1"/>
-          </p:cNvSpPr>
-          <p:nvPr>
-            <p:ph type="title"/>
-          </p:nvPr>
-        </p:nvSpPr>
-        <p:spPr/>
-        <p:txBody>
-          <a:bodyPr/>
-          <a:lstStyle/>
-          <a:p>
-            <a:r>
-              <a:rPr lang="en-US"/>
-              <a:t>Q&amp;A</a:t>
-            </a:r>
-          </a:p>
-        </p:txBody>
-      </p:sp>
-      <p:sp>
-        <p:nvSpPr>
-          <p:cNvPr id="3" name="Slide Number Placeholder 2"/>
-          <p:cNvSpPr>
-            <a:spLocks noGrp="1"/>
-          </p:cNvSpPr>
-          <p:nvPr>
-            <p:ph type="sldNum" idx="12"/>
-          </p:nvPr>
-        </p:nvSpPr>
-        <p:spPr/>
-        <p:txBody>
-          <a:bodyPr/>
-          <a:lstStyle/>
-          <a:p>
-            <a:pPr algn="r"/>
-            <a:fld id="{CAD2D6BD-DE1B-4B5F-8B41-2702339687B9}" type="slidenum">
-              <a:rPr lang="en-US" altLang="zh-CN" smtClean="0">
-                <a:solidFill>
-                  <a:srgbClr val="888888"/>
-                </a:solidFill>
-                <a:ea typeface="Calibri" charset="0"/>
-                <a:sym typeface="Calibri" charset="0"/>
-              </a:rPr>
-              <a:pPr algn="r"/>
-              <a:t>9</a:t>
-            </a:fld>
-            <a:endParaRPr lang="zh-CN" altLang="en-US">
-              <a:solidFill>
-                <a:srgbClr val="888888"/>
-              </a:solidFill>
-              <a:ea typeface="Calibri" charset="0"/>
-              <a:sym typeface="Calibri" charset="0"/>
-            </a:endParaRPr>
-          </a:p>
-        </p:txBody>
-      </p:sp>
-      <p:sp>
-        <p:nvSpPr>
-          <p:cNvPr id="4" name="Text Placeholder 3"/>
-          <p:cNvSpPr>
-            <a:spLocks noGrp="1"/>
-          </p:cNvSpPr>
-          <p:nvPr>
-            <p:ph type="body" sz="quarter" idx="13"/>
-          </p:nvPr>
-        </p:nvSpPr>
-        <p:spPr/>
-        <p:txBody>
-          <a:bodyPr/>
-          <a:lstStyle/>
-          <a:p>
-            <a:r>
-              <a:rPr lang="en-US"/>
-              <a:t>Any Questions?</a:t>
-            </a:r>
-          </a:p>
-        </p:txBody>
-      </p:sp>
-    </p:spTree>
-    <p:extLst>
-      <p:ext uri="{BB962C8B-B14F-4D97-AF65-F5344CB8AC3E}">
-        <p14:creationId xmlns:p14="http://schemas.microsoft.com/office/powerpoint/2010/main" val="15486131"/>
-      </p:ext>
-    </p:extLst>
   </p:cSld>
   <p:clrMapOvr>
     <a:masterClrMapping/>
@@ -21822,18 +22638,18 @@
 </file>
 
 <file path=customXml/item1.xml><?xml version="1.0" encoding="utf-8"?>
-<p:properties xmlns:p="http://schemas.microsoft.com/office/2006/metadata/properties" xmlns:xsi="http://www.w3.org/2001/XMLSchema-instance" xmlns:pc="http://schemas.microsoft.com/office/infopath/2007/PartnerControls">
-  <documentManagement/>
-</p:properties>
-</file>
-
-<file path=customXml/item2.xml><?xml version="1.0" encoding="utf-8"?>
 <?mso-contentType ?>
 <FormTemplates xmlns="http://schemas.microsoft.com/sharepoint/v3/contenttype/forms">
   <Display>DocumentLibraryForm</Display>
   <Edit>DocumentLibraryForm</Edit>
   <New>DocumentLibraryForm</New>
 </FormTemplates>
+</file>
+
+<file path=customXml/item2.xml><?xml version="1.0" encoding="utf-8"?>
+<p:properties xmlns:p="http://schemas.microsoft.com/office/2006/metadata/properties" xmlns:xsi="http://www.w3.org/2001/XMLSchema-instance" xmlns:pc="http://schemas.microsoft.com/office/infopath/2007/PartnerControls">
+  <documentManagement/>
+</p:properties>
 </file>
 
 <file path=customXml/item3.xml><?xml version="1.0" encoding="utf-8"?>
@@ -21975,18 +22791,18 @@
 </file>
 
 <file path=customXml/itemProps1.xml><?xml version="1.0" encoding="utf-8"?>
-<ds:datastoreItem xmlns:ds="http://schemas.openxmlformats.org/officeDocument/2006/customXml" ds:itemID="{B561DBE2-C7D3-4BB5-AC84-2E5A62EC767F}">
+<ds:datastoreItem xmlns:ds="http://schemas.openxmlformats.org/officeDocument/2006/customXml" ds:itemID="{480A8CC9-6CB9-4442-A4A0-CCC1121C5A83}">
   <ds:schemaRefs>
-    <ds:schemaRef ds:uri="http://schemas.microsoft.com/office/2006/metadata/properties"/>
-    <ds:schemaRef ds:uri="http://schemas.microsoft.com/office/infopath/2007/PartnerControls"/>
+    <ds:schemaRef ds:uri="http://schemas.microsoft.com/sharepoint/v3/contenttype/forms"/>
   </ds:schemaRefs>
 </ds:datastoreItem>
 </file>
 
 <file path=customXml/itemProps2.xml><?xml version="1.0" encoding="utf-8"?>
-<ds:datastoreItem xmlns:ds="http://schemas.openxmlformats.org/officeDocument/2006/customXml" ds:itemID="{480A8CC9-6CB9-4442-A4A0-CCC1121C5A83}">
+<ds:datastoreItem xmlns:ds="http://schemas.openxmlformats.org/officeDocument/2006/customXml" ds:itemID="{B561DBE2-C7D3-4BB5-AC84-2E5A62EC767F}">
   <ds:schemaRefs>
-    <ds:schemaRef ds:uri="http://schemas.microsoft.com/sharepoint/v3/contenttype/forms"/>
+    <ds:schemaRef ds:uri="http://schemas.microsoft.com/office/2006/metadata/properties"/>
+    <ds:schemaRef ds:uri="http://schemas.microsoft.com/office/infopath/2007/PartnerControls"/>
   </ds:schemaRefs>
 </ds:datastoreItem>
 </file>

</xml_diff>